<commit_message>
Inclui nos slides de Estado, Governo e Mercado as tabelas da página de conteúdos
Fatores de produção, sistemas econômicos, conceitos fundamentais,
funções de Musgrave e o quadro liberal x marxista passam a reproduzir
as tabelas da página; roteiro de gravação ajustado.

Co-Authored-By: Claude Opus 5.5 <noreply@anthropic.com>
Claude-Session: https://claude.ai/code/session_01PyQDDPKwUxu1Vg7o8uyr7W
</commit_message>
<xml_diff>
--- a/disciplina-01-estado-governo-mercado/materiais/03_Unidade_3_Matriz_Marxista.pptx
+++ b/disciplina-01-estado-governo-mercado/materiais/03_Unidade_3_Matriz_Marxista.pptx
@@ -1052,7 +1052,7 @@
           <a:p>
             <a:r>
               <a:rPr lang="en-US" dirty="0"/>
-              <a:t>Este quadro resume as duas matrizes. Sobre o mercado: para os liberais, é eficiente e natural; para os marxistas, é lugar de exploração e de crises. Sobre o Estado: para os liberais, garante direitos e deve ser limitado; para os marxistas, é instrumento de dominação de classe. A unidade de análise do liberalismo é o indivíduo; a do marxismo, as classes sociais. A propriedade privada é direito natural para uns e base da exploração para outros. E o horizonte: aperfeiçoar o capitalismo, de um lado, ou superá-lo, do outro. Este quadro é uma ótima ferramenta de revisão para a A2 e a A3.</a:t>
+              <a:t>Este quadro resume as duas matrizes. Sobre o mercado: para os liberais, é eficiente e natural; para os marxistas, é lugar de exploração e de crises. Sobre o Estado: para os liberais, garante direitos e deve ser limitado; para os marxistas, é instrumento de dominação de classe. Quanto ao foco, o liberalismo olha para o indivíduo livre e proprietário; o marxismo, para as classes sociais e o seu conflito. A propriedade privada é direito natural e base da liberdade para os liberais; para os marxistas, é a base da exploração e deve ser socializada. E o horizonte: aperfeiçoar o capitalismo, de um lado, ou superá-lo, do outro. Este quadro é uma ótima ferramenta de revisão para a A2 e a A3.</a:t>
             </a:r>
             <a:endParaRPr lang="en-US" dirty="0"/>
           </a:p>
@@ -4796,17 +4796,17 @@
           </p:nvPr>
         </p:nvGraphicFramePr>
         <p:xfrm>
-          <a:off x="822960" y="1234440"/>
-          <a:ext cx="7498080" cy="914400"/>
+          <a:off x="685800" y="1188720"/>
+          <a:ext cx="7772400" cy="914400"/>
         </p:xfrm>
         <a:graphic>
           <a:graphicData uri="http://schemas.openxmlformats.org/drawingml/2006/table">
             <a:tbl>
               <a:tblPr/>
               <a:tblGrid>
-                <a:gridCol w="2103120"/>
-                <a:gridCol w="2697480"/>
-                <a:gridCol w="2697480"/>
+                <a:gridCol w="1737360"/>
+                <a:gridCol w="3017520"/>
+                <a:gridCol w="3017520"/>
               </a:tblGrid>
               <a:tr h="0">
                 <a:tc>
@@ -4817,7 +4817,7 @@
                       <a:pPr indent="0" marL="0">
                         <a:buNone/>
                       </a:pPr>
-                      <a:endParaRPr lang="en-US" sz="1400" dirty="0">
+                      <a:endParaRPr lang="en-US" sz="1600" dirty="0">
                         <a:latin typeface="Calibri" charset="0"/>
                         <a:ea typeface="Calibri" charset="0"/>
                         <a:cs typeface="Calibri" charset="0"/>
@@ -4875,7 +4875,7 @@
                         <a:buNone/>
                       </a:pPr>
                       <a:r>
-                        <a:rPr lang="en-US" sz="1400" b="1" dirty="0">
+                        <a:rPr lang="en-US" sz="1600" b="1" dirty="0">
                           <a:solidFill>
                             <a:srgbClr val="FFFFFF"/>
                           </a:solidFill>
@@ -4885,7 +4885,7 @@
                         </a:rPr>
                         <a:t>Matriz liberal</a:t>
                       </a:r>
-                      <a:endParaRPr lang="en-US" sz="1400" dirty="0">
+                      <a:endParaRPr lang="en-US" sz="1600" dirty="0">
                         <a:latin typeface="Calibri" charset="0"/>
                         <a:ea typeface="Calibri" charset="0"/>
                         <a:cs typeface="Calibri" charset="0"/>
@@ -4943,7 +4943,7 @@
                         <a:buNone/>
                       </a:pPr>
                       <a:r>
-                        <a:rPr lang="en-US" sz="1400" b="1" dirty="0">
+                        <a:rPr lang="en-US" sz="1600" b="1" dirty="0">
                           <a:solidFill>
                             <a:srgbClr val="FFFFFF"/>
                           </a:solidFill>
@@ -4953,7 +4953,7 @@
                         </a:rPr>
                         <a:t>Matriz marxista</a:t>
                       </a:r>
-                      <a:endParaRPr lang="en-US" sz="1400" dirty="0">
+                      <a:endParaRPr lang="en-US" sz="1600" dirty="0">
                         <a:latin typeface="Calibri" charset="0"/>
                         <a:ea typeface="Calibri" charset="0"/>
                         <a:cs typeface="Calibri" charset="0"/>
@@ -5013,7 +5013,7 @@
                         <a:buNone/>
                       </a:pPr>
                       <a:r>
-                        <a:rPr lang="en-US" sz="1400" b="1" dirty="0">
+                        <a:rPr lang="en-US" sz="1600" b="1" dirty="0">
                           <a:solidFill>
                             <a:srgbClr val="1F2A37"/>
                           </a:solidFill>
@@ -5023,7 +5023,7 @@
                         </a:rPr>
                         <a:t>Mercado</a:t>
                       </a:r>
-                      <a:endParaRPr lang="en-US" sz="1400" dirty="0">
+                      <a:endParaRPr lang="en-US" sz="1600" dirty="0">
                         <a:latin typeface="Calibri" charset="0"/>
                         <a:ea typeface="Calibri" charset="0"/>
                         <a:cs typeface="Calibri" charset="0"/>
@@ -5081,7 +5081,7 @@
                         <a:buNone/>
                       </a:pPr>
                       <a:r>
-                        <a:rPr lang="en-US" sz="1400" dirty="0">
+                        <a:rPr lang="en-US" sz="1600" dirty="0">
                           <a:solidFill>
                             <a:srgbClr val="1F2A37"/>
                           </a:solidFill>
@@ -5089,9 +5089,9 @@
                           <a:ea typeface="Calibri" pitchFamily="34" charset="-122"/>
                           <a:cs typeface="Calibri" pitchFamily="34" charset="-120"/>
                         </a:rPr>
-                        <a:t>Eficiente e natural</a:t>
+                        <a:t>Mecanismo eficiente e natural de coordenação</a:t>
                       </a:r>
-                      <a:endParaRPr lang="en-US" sz="1400" dirty="0">
+                      <a:endParaRPr lang="en-US" sz="1600" dirty="0">
                         <a:latin typeface="Calibri" charset="0"/>
                         <a:ea typeface="Calibri" charset="0"/>
                         <a:cs typeface="Calibri" charset="0"/>
@@ -5149,7 +5149,7 @@
                         <a:buNone/>
                       </a:pPr>
                       <a:r>
-                        <a:rPr lang="en-US" sz="1400" dirty="0">
+                        <a:rPr lang="en-US" sz="1600" dirty="0">
                           <a:solidFill>
                             <a:srgbClr val="1F2A37"/>
                           </a:solidFill>
@@ -5157,9 +5157,9 @@
                           <a:ea typeface="Calibri" pitchFamily="34" charset="-122"/>
                           <a:cs typeface="Calibri" pitchFamily="34" charset="-120"/>
                         </a:rPr>
-                        <a:t>Exploração e crises</a:t>
+                        <a:t>Espaço de exploração e fonte de crises</a:t>
                       </a:r>
-                      <a:endParaRPr lang="en-US" sz="1400" dirty="0">
+                      <a:endParaRPr lang="en-US" sz="1600" dirty="0">
                         <a:latin typeface="Calibri" charset="0"/>
                         <a:ea typeface="Calibri" charset="0"/>
                         <a:cs typeface="Calibri" charset="0"/>
@@ -5219,7 +5219,7 @@
                         <a:buNone/>
                       </a:pPr>
                       <a:r>
-                        <a:rPr lang="en-US" sz="1400" b="1" dirty="0">
+                        <a:rPr lang="en-US" sz="1600" b="1" dirty="0">
                           <a:solidFill>
                             <a:srgbClr val="1F2A37"/>
                           </a:solidFill>
@@ -5229,7 +5229,7 @@
                         </a:rPr>
                         <a:t>Estado</a:t>
                       </a:r>
-                      <a:endParaRPr lang="en-US" sz="1400" dirty="0">
+                      <a:endParaRPr lang="en-US" sz="1600" dirty="0">
                         <a:latin typeface="Calibri" charset="0"/>
                         <a:ea typeface="Calibri" charset="0"/>
                         <a:cs typeface="Calibri" charset="0"/>
@@ -5287,7 +5287,7 @@
                         <a:buNone/>
                       </a:pPr>
                       <a:r>
-                        <a:rPr lang="en-US" sz="1400" dirty="0">
+                        <a:rPr lang="en-US" sz="1600" dirty="0">
                           <a:solidFill>
                             <a:srgbClr val="1F2A37"/>
                           </a:solidFill>
@@ -5295,9 +5295,9 @@
                           <a:ea typeface="Calibri" pitchFamily="34" charset="-122"/>
                           <a:cs typeface="Calibri" pitchFamily="34" charset="-120"/>
                         </a:rPr>
-                        <a:t>Garante direitos; deve ser limitado</a:t>
+                        <a:t>Garantidor de direitos e contratos; deve ser limitado</a:t>
                       </a:r>
-                      <a:endParaRPr lang="en-US" sz="1400" dirty="0">
+                      <a:endParaRPr lang="en-US" sz="1600" dirty="0">
                         <a:latin typeface="Calibri" charset="0"/>
                         <a:ea typeface="Calibri" charset="0"/>
                         <a:cs typeface="Calibri" charset="0"/>
@@ -5355,7 +5355,7 @@
                         <a:buNone/>
                       </a:pPr>
                       <a:r>
-                        <a:rPr lang="en-US" sz="1400" dirty="0">
+                        <a:rPr lang="en-US" sz="1600" dirty="0">
                           <a:solidFill>
                             <a:srgbClr val="1F2A37"/>
                           </a:solidFill>
@@ -5363,9 +5363,9 @@
                           <a:ea typeface="Calibri" pitchFamily="34" charset="-122"/>
                           <a:cs typeface="Calibri" pitchFamily="34" charset="-120"/>
                         </a:rPr>
-                        <a:t>Instrumento de dominação de classe</a:t>
+                        <a:t>Instrumento de dominação da classe dominante</a:t>
                       </a:r>
-                      <a:endParaRPr lang="en-US" sz="1400" dirty="0">
+                      <a:endParaRPr lang="en-US" sz="1600" dirty="0">
                         <a:latin typeface="Calibri" charset="0"/>
                         <a:ea typeface="Calibri" charset="0"/>
                         <a:cs typeface="Calibri" charset="0"/>
@@ -5425,7 +5425,7 @@
                         <a:buNone/>
                       </a:pPr>
                       <a:r>
-                        <a:rPr lang="en-US" sz="1400" b="1" dirty="0">
+                        <a:rPr lang="en-US" sz="1600" b="1" dirty="0">
                           <a:solidFill>
                             <a:srgbClr val="1F2A37"/>
                           </a:solidFill>
@@ -5433,9 +5433,9 @@
                           <a:ea typeface="Calibri" pitchFamily="34" charset="-122"/>
                           <a:cs typeface="Calibri" pitchFamily="34" charset="-120"/>
                         </a:rPr>
-                        <a:t>Unidade de análise</a:t>
+                        <a:t>Indivíduo / classe</a:t>
                       </a:r>
-                      <a:endParaRPr lang="en-US" sz="1400" dirty="0">
+                      <a:endParaRPr lang="en-US" sz="1600" dirty="0">
                         <a:latin typeface="Calibri" charset="0"/>
                         <a:ea typeface="Calibri" charset="0"/>
                         <a:cs typeface="Calibri" charset="0"/>
@@ -5493,7 +5493,7 @@
                         <a:buNone/>
                       </a:pPr>
                       <a:r>
-                        <a:rPr lang="en-US" sz="1400" dirty="0">
+                        <a:rPr lang="en-US" sz="1600" dirty="0">
                           <a:solidFill>
                             <a:srgbClr val="1F2A37"/>
                           </a:solidFill>
@@ -5501,9 +5501,9 @@
                           <a:ea typeface="Calibri" pitchFamily="34" charset="-122"/>
                           <a:cs typeface="Calibri" pitchFamily="34" charset="-120"/>
                         </a:rPr>
-                        <a:t>Indivíduo</a:t>
+                        <a:t>Foco no indivíduo livre e proprietário</a:t>
                       </a:r>
-                      <a:endParaRPr lang="en-US" sz="1400" dirty="0">
+                      <a:endParaRPr lang="en-US" sz="1600" dirty="0">
                         <a:latin typeface="Calibri" charset="0"/>
                         <a:ea typeface="Calibri" charset="0"/>
                         <a:cs typeface="Calibri" charset="0"/>
@@ -5561,7 +5561,7 @@
                         <a:buNone/>
                       </a:pPr>
                       <a:r>
-                        <a:rPr lang="en-US" sz="1400" dirty="0">
+                        <a:rPr lang="en-US" sz="1600" dirty="0">
                           <a:solidFill>
                             <a:srgbClr val="1F2A37"/>
                           </a:solidFill>
@@ -5569,9 +5569,9 @@
                           <a:ea typeface="Calibri" pitchFamily="34" charset="-122"/>
                           <a:cs typeface="Calibri" pitchFamily="34" charset="-120"/>
                         </a:rPr>
-                        <a:t>Classes sociais</a:t>
+                        <a:t>Foco nas classes sociais e em seu conflito</a:t>
                       </a:r>
-                      <a:endParaRPr lang="en-US" sz="1400" dirty="0">
+                      <a:endParaRPr lang="en-US" sz="1600" dirty="0">
                         <a:latin typeface="Calibri" charset="0"/>
                         <a:ea typeface="Calibri" charset="0"/>
                         <a:cs typeface="Calibri" charset="0"/>
@@ -5631,7 +5631,7 @@
                         <a:buNone/>
                       </a:pPr>
                       <a:r>
-                        <a:rPr lang="en-US" sz="1400" b="1" dirty="0">
+                        <a:rPr lang="en-US" sz="1600" b="1" dirty="0">
                           <a:solidFill>
                             <a:srgbClr val="1F2A37"/>
                           </a:solidFill>
@@ -5641,7 +5641,7 @@
                         </a:rPr>
                         <a:t>Propriedade privada</a:t>
                       </a:r>
-                      <a:endParaRPr lang="en-US" sz="1400" dirty="0">
+                      <a:endParaRPr lang="en-US" sz="1600" dirty="0">
                         <a:latin typeface="Calibri" charset="0"/>
                         <a:ea typeface="Calibri" charset="0"/>
                         <a:cs typeface="Calibri" charset="0"/>
@@ -5699,7 +5699,7 @@
                         <a:buNone/>
                       </a:pPr>
                       <a:r>
-                        <a:rPr lang="en-US" sz="1400" dirty="0">
+                        <a:rPr lang="en-US" sz="1600" dirty="0">
                           <a:solidFill>
                             <a:srgbClr val="1F2A37"/>
                           </a:solidFill>
@@ -5707,9 +5707,9 @@
                           <a:ea typeface="Calibri" pitchFamily="34" charset="-122"/>
                           <a:cs typeface="Calibri" pitchFamily="34" charset="-120"/>
                         </a:rPr>
-                        <a:t>Direito natural</a:t>
+                        <a:t>Direito natural, base da liberdade</a:t>
                       </a:r>
-                      <a:endParaRPr lang="en-US" sz="1400" dirty="0">
+                      <a:endParaRPr lang="en-US" sz="1600" dirty="0">
                         <a:latin typeface="Calibri" charset="0"/>
                         <a:ea typeface="Calibri" charset="0"/>
                         <a:cs typeface="Calibri" charset="0"/>
@@ -5767,7 +5767,7 @@
                         <a:buNone/>
                       </a:pPr>
                       <a:r>
-                        <a:rPr lang="en-US" sz="1400" dirty="0">
+                        <a:rPr lang="en-US" sz="1600" dirty="0">
                           <a:solidFill>
                             <a:srgbClr val="1F2A37"/>
                           </a:solidFill>
@@ -5775,9 +5775,9 @@
                           <a:ea typeface="Calibri" pitchFamily="34" charset="-122"/>
                           <a:cs typeface="Calibri" pitchFamily="34" charset="-120"/>
                         </a:rPr>
-                        <a:t>Base da exploração</a:t>
+                        <a:t>Base da exploração, deve ser socializada</a:t>
                       </a:r>
-                      <a:endParaRPr lang="en-US" sz="1400" dirty="0">
+                      <a:endParaRPr lang="en-US" sz="1600" dirty="0">
                         <a:latin typeface="Calibri" charset="0"/>
                         <a:ea typeface="Calibri" charset="0"/>
                         <a:cs typeface="Calibri" charset="0"/>
@@ -5837,7 +5837,7 @@
                         <a:buNone/>
                       </a:pPr>
                       <a:r>
-                        <a:rPr lang="en-US" sz="1400" b="1" dirty="0">
+                        <a:rPr lang="en-US" sz="1600" b="1" dirty="0">
                           <a:solidFill>
                             <a:srgbClr val="1F2A37"/>
                           </a:solidFill>
@@ -5847,7 +5847,7 @@
                         </a:rPr>
                         <a:t>Horizonte</a:t>
                       </a:r>
-                      <a:endParaRPr lang="en-US" sz="1400" dirty="0">
+                      <a:endParaRPr lang="en-US" sz="1600" dirty="0">
                         <a:latin typeface="Calibri" charset="0"/>
                         <a:ea typeface="Calibri" charset="0"/>
                         <a:cs typeface="Calibri" charset="0"/>
@@ -5905,7 +5905,7 @@
                         <a:buNone/>
                       </a:pPr>
                       <a:r>
-                        <a:rPr lang="en-US" sz="1400" dirty="0">
+                        <a:rPr lang="en-US" sz="1600" dirty="0">
                           <a:solidFill>
                             <a:srgbClr val="1F2A37"/>
                           </a:solidFill>
@@ -5915,7 +5915,7 @@
                         </a:rPr>
                         <a:t>Aperfeiçoar o capitalismo</a:t>
                       </a:r>
-                      <a:endParaRPr lang="en-US" sz="1400" dirty="0">
+                      <a:endParaRPr lang="en-US" sz="1600" dirty="0">
                         <a:latin typeface="Calibri" charset="0"/>
                         <a:ea typeface="Calibri" charset="0"/>
                         <a:cs typeface="Calibri" charset="0"/>
@@ -5973,7 +5973,7 @@
                         <a:buNone/>
                       </a:pPr>
                       <a:r>
-                        <a:rPr lang="en-US" sz="1400" dirty="0">
+                        <a:rPr lang="en-US" sz="1600" dirty="0">
                           <a:solidFill>
                             <a:srgbClr val="1F2A37"/>
                           </a:solidFill>
@@ -5983,7 +5983,7 @@
                         </a:rPr>
                         <a:t>Superar o capitalismo</a:t>
                       </a:r>
-                      <a:endParaRPr lang="en-US" sz="1400" dirty="0">
+                      <a:endParaRPr lang="en-US" sz="1600" dirty="0">
                         <a:latin typeface="Calibri" charset="0"/>
                         <a:ea typeface="Calibri" charset="0"/>
                         <a:cs typeface="Calibri" charset="0"/>

</xml_diff>